<commit_message>
docs: met à jour la documentation suite à l'intégration de la vraie IA
- Cahier des charges technique : nouvelle sous-section documentant
  l'exception serverless (assistant IA via Gemini), mise à jour de la
  synthèse technique et du tableau des risques de sécurité (clé API
  désormais isolée côté serveur, plus seulement une intention).
- DEVOPS.md : nouvelle section sur la fonction serverless et la
  gestion du secret GEMINI_API_KEY, mise à jour de la sécurité
  opérationnelle et des évolutions possibles.
- Gestion_Projet_Ryan_CHAIBAT.docx : ajoute /api à la structure du
  dépôt documentée.
- Soutenance_Ryan_CHAIBAT.pptx : nuance le choix "pas de back-end"
  (données uniquement), et mentionne l'intégration réelle de l'IA sur
  les slides Choix technique, Modules IA et Déploiement continu.
</commit_message>
<xml_diff>
--- a/Document/Soutenance_Ryan_CHAIBAT.pptx
+++ b/Document/Soutenance_Ryan_CHAIBAT.pptx
@@ -3840,7 +3840,7 @@
                 <a:ea typeface="Calibri" pitchFamily="34" charset="-122"/>
                 <a:cs typeface="Calibri" pitchFamily="34" charset="-120"/>
               </a:rPr>
-              <a:t>Architecture commune : service simulé isolé, données réelles injectées, remplaçable par API sans toucher l'affichage. Aucune clé exposée.</a:t>
+              <a:t>Architecture commune : service isolé, données réelles injectées. L'assistant conversationnel utilise déjà une vraie IA (Gemini) via une fonction serverless, sans clé exposée côté client.</a:t>
             </a:r>
             <a:endParaRPr lang="en-US" sz="1100" dirty="0"/>
           </a:p>
@@ -14872,7 +14872,7 @@
                 <a:ea typeface="Calibri" pitchFamily="34" charset="-122"/>
                 <a:cs typeface="Calibri" pitchFamily="34" charset="-120"/>
               </a:rPr>
-              <a:t>Déploiement automatique à chaque push sur main, HTTPS natif.</a:t>
+              <a:t>Déploiement auto, HTTPS natif, secrets IA chiffrés.</a:t>
             </a:r>
             <a:endParaRPr lang="en-US" sz="1150" dirty="0"/>
           </a:p>
@@ -21524,7 +21524,7 @@
                 <a:ea typeface="Cambria" pitchFamily="34" charset="-122"/>
                 <a:cs typeface="Cambria" pitchFamily="34" charset="-120"/>
               </a:rPr>
-              <a:t>Un choix clair : pas de back-end serveur</a:t>
+              <a:t>Un choix clair : pas de back-end pour les données</a:t>
             </a:r>
             <a:endParaRPr lang="en-US" sz="3000" dirty="0"/>
           </a:p>
@@ -21698,7 +21698,7 @@
                 <a:ea typeface="Calibri" pitchFamily="34" charset="-122"/>
                 <a:cs typeface="Calibri" pitchFamily="34" charset="-120"/>
               </a:rPr>
-              <a:t>Architecture en couches : la couche service est isolée et remplaçable sans refonte.</a:t>
+              <a:t>Architecture en couches : la couche service est isolée — déjà vérifié avec l'assistant IA.</a:t>
             </a:r>
             <a:endParaRPr lang="en-US" sz="1300" dirty="0"/>
           </a:p>

</xml_diff>